<commit_message>
added lab 2.b walkthroughs
</commit_message>
<xml_diff>
--- a/docs/instructor/lab-2a-writing-the-standards-down.pptx
+++ b/docs/instructor/lab-2a-writing-the-standards-down.pptx
@@ -1091,7 +1091,7 @@
           <a:lstStyle/>
           <a:p>
             <a:r>
-              <a:t>[CALIBRATED from Lab 1.b, 2026-08-12: agenda held · prompting depth right · checkpoint gates worked · mostly solo, fine · room waits to be told → 4 seed clauses + 10-min derive] This is the follow-along increment — everyone in the same state before the checkpoint. If anyone skipped the handout prep, now is when it bites: branch `feat/governance`, docs/labs pulled. Circulate; the common stall is over-polishing Context. Ten minutes, hard stop. Fast finishers: point at the stretch — derive the store-boundary clause list early, or review a neighbour's draft Decision. COMMON QUESTIONS — Q: "Same subject as yours — is that not just copying?" A: the MOTION is the point: your prompts, your edit, your Decision sentence, your cost; next week the subject is one nobody has modelled. Q: "What if I disagree with the repository pattern?" A: perfect — record it anyway (Status: Accepted; it IS this repo's reality) and put your objection in Consequences as a cost; recording is not endorsing, and in real life your objection becomes a superseding ADR proposal. Q: "Commit now or at the end?" A: commit to feat/governance now — small commits, one PR at the end of the block. Q: "My ADR came out nearly identical to the demo." A: expected on a shared subject; the checkpoint checks the metadata block, three sections, and a real cost — not originality. ~11 min.</a:t>
+              <a:t>[CALIBRATED from Lab 1.b, 2026-08-12: agenda held · prompting depth right · checkpoint gates worked · mostly solo, fine · room waits to be told → 4 seed clauses + 10-min derive] This is the follow-along increment — everyone in the same state before the checkpoint. If anyone skipped the handout prep, now is when it bites: branch `feat/governance`, docs/labs pulled. Remote circulation: one chat nudge at ~5 min ("stuck on Context? Slack me"); the common stall is over-polishing Context. Ten minutes, hard stop. Fast finishers: point at the stretch — derive the store-boundary clause list early, or review a neighbour's draft Decision. COMMON QUESTIONS — Q: "Same subject as yours — is that not just copying?" A: the MOTION is the point: your prompts, your edit, your Decision sentence, your cost; next week the subject is one nobody has modelled. Q: "What if I disagree with the repository pattern?" A: perfect — record it anyway (Status: Accepted; it IS this repo's reality) and put your objection in Consequences as a cost; recording is not endorsing, and in real life your objection becomes a superseding ADR proposal. Q: "Commit now or at the end?" A: commit to feat/governance now — small commits, one PR at the end of the block. Q: "My ADR came out nearly identical to the demo." A: expected on a shared subject; the checkpoint checks the metadata block, three sections, and a real cost — not originality. ~11 min.</a:t>
             </a:r>
           </a:p>
         </p:txBody>
@@ -1161,7 +1161,7 @@
           <a:lstStyle/>
           <a:p>
             <a:r>
-              <a:t>[CALIBRATED from Lab 1.b, 2026-08-12: agenda held · prompting depth right · checkpoint gates worked · mostly solo, fine · room waits to be told → 4 seed clauses + 10-min derive] Do not advance past unresolved hands. Cheap to verify by walking the room. If more than two people are stuck, the cause is usually prompt shape — show yours again. Fast finishers go to the stretch list (handout): the store-boundary clauses or a peer review. ~3 min.</a:t>
+              <a:t>[CALIBRATED from Lab 1.b, 2026-08-12: agenda held · prompting depth right · checkpoint gates worked · mostly solo, fine · room waits to be told → 4 seed clauses + 10-min derive] Chat is the room-walk: Decision sentences land where you can read them, and a missing name is your signal (Slack them, not the whole call). If more than two people are stuck, the cause is usually prompt shape — show yours again. Fast finishers go to the stretch list (handout): the store-boundary clauses or a peer review. ~3 min.</a:t>
             </a:r>
           </a:p>
         </p:txBody>
@@ -1301,7 +1301,7 @@
           <a:lstStyle/>
           <a:p>
             <a:r>
-              <a:t>[CALIBRATED from Lab 1.b, 2026-08-12: agenda held · prompting depth right · checkpoint gates worked · mostly solo, fine · room waits to be told → 4 seed clauses + 10-min derive] The blocks sum to 120 — keep yourself honest on them. No setup block: everyone arrives ready per the handout (branch created, docs/labs pulled, npm test green) — verify that claim with a ten-second show of hands here, and pair any exception quietly during the Why slide rather than stopping the room. Set expectations: this block is less typing than 1.b and more deciding. Two unusual asks today: read code cold and write a rule from it, and mark which parts of your own rule a machine could not check. Also say once: how you're assessed is on the handout — same five-dimension rubric as Lab 1, counts toward Agentic Developer. ~2 min.</a:t>
+              <a:t>[CALIBRATED from Lab 1.b, 2026-08-12: agenda held · prompting depth right · checkpoint gates worked · mostly solo, fine · room waits to be told → 4 seed clauses + 10-min derive] The blocks sum to 120 — keep yourself honest on them. No setup block: everyone arrives ready per the handout (branch created, docs/labs pulled, npm test green) — verify in chat ("type READY if npm test is green on your branch"), and route any exception to Slack during the Why slide rather than stopping the call. Set expectations: this block is less typing than 1.b and more deciding. Two unusual asks today: read code cold and write a rule from it, and mark which parts of your own rule a machine could not check. Also say once: how you're assessed is on the handout — same five-dimension rubric as Lab 1, counts toward Agentic Developer. ~2 min.</a:t>
             </a:r>
           </a:p>
         </p:txBody>
@@ -1861,7 +1861,7 @@
           <a:lstStyle/>
           <a:p>
             <a:r>
-              <a:t>[CALIBRATED from Lab 1.b, 2026-08-12: agenda held · prompting depth right · checkpoint gates worked · mostly solo, fine · room waits to be told → 4 seed clauses + 10-min derive] Ask each group to read one fuzzy clause and its recorded decision aloud — two minutes, and it makes the standard real. The common failure here: a "Checked by: code review" line on every clause — that is the human gate as a reflex, not a decision; push once: "could a script check THIS one?" Fast finishers: the half-gate stretch (write the ESLint clause) or the rules-file conversion. ~2 min.</a:t>
+              <a:t>[CALIBRATED from Lab 1.b, 2026-08-12: agenda held · prompting depth right · checkpoint gates worked · mostly solo, fine · room waits to be told → 4 seed clauses + 10-min derive] Ask one voice per group to unmute and read a fuzzy clause with its recorded decision — two minutes, and it makes the standard real. The common failure here: a "Checked by: code review" line on every clause — that is the human gate as a reflex, not a decision; push once: "could a script check THIS one?" Fast finishers: the half-gate stretch (write the ESLint clause) or the rules-file conversion. ~2 min.</a:t>
             </a:r>
           </a:p>
         </p:txBody>
@@ -2001,7 +2001,7 @@
           <a:lstStyle/>
           <a:p>
             <a:r>
-              <a:t>[CALIBRATED from Lab 1.b, 2026-08-12: agenda held · prompting depth right · checkpoint gates worked · mostly solo, fine · room waits to be told → 4 seed clauses + 10-min derive] Do not skip this to buy build time — it is the review+capture close Format B requires. INSTRUCTOR, within 24h: file the lab-capture entry (AI-Transformation-Playbook/04-labs/lab-capture-template.md) — what was built, stuck points, timings, refinements. This deck is the Format B pilot; the capture entry is how it gets validated. ~4 min.</a:t>
+              <a:t>[CALIBRATED from Lab 1.b, 2026-08-12: agenda held · prompting depth right · checkpoint gates worked · mostly solo, fine · room waits to be told → 4 seed clauses + 10-min derive] Do not skip this to buy build time — it is the review+capture close Format B requires. COPY THE CHAT BEFORE ENDING THE CALL — Meet deletes it, and the Decision sentences, the AGREED clause list, and the retro lines all feed the capture. INSTRUCTOR, within 24h: file the lab-capture entry (AI-Transformation-Playbook/04-labs/lab-capture-template.md) — what was built, stuck points, timings, refinements. This deck is the Format B pilot; the capture entry is how it gets validated. ~4 min.</a:t>
             </a:r>
           </a:p>
         </p:txBody>
@@ -2071,7 +2071,7 @@
           <a:lstStyle/>
           <a:p>
             <a:r>
-              <a:t>Do not oversell — this room is already positive about AI; the pitch is "stop solving the same problem sixteen times." Land the vocabulary on card 3, once, and reuse it all day: a RULE is what the team agrees on; a DOCUMENT is where the rule lives (one document can hold many rules); a rule written down and agreed is a STANDARD — the same definition the distribution guide uses. Then land the ETH note: the point is not "AI cannot write docs", it is that a doc nobody thought about is negative value. Ask who has run /init and never read the output — hands will go up. Source link is in the handout. ~3 min.</a:t>
+              <a:t>Do not oversell — this room is already positive about AI; the pitch is "stop solving the same problem sixteen times." Land the vocabulary on card 3, once, and reuse it all day: a RULE is what the team agrees on; a DOCUMENT is where the rule lives (one document can hold many rules); a rule written down and agreed is a STANDARD — the same definition the distribution guide uses. Then land the ETH note: the point is not "AI cannot write docs", it is that a doc nobody thought about is negative value. Ask who has run /init and never read the output in chat, as a +1 — the +1s will come. Source link is in the handout. ~3 min.</a:t>
             </a:r>
           </a:p>
         </p:txBody>
@@ -12428,7 +12428,7 @@
                 </a:solidFill>
                 <a:latin typeface="Arial"/>
               </a:rPr>
-              <a:t>Thumbs up, or say so. If your Decision line came out of Claude rather than out of you, rewrite it now — that is the one part of an ADR that cannot be delegated.</a:t>
+              <a:t>Paste your Decision sentence into chat. If it came out of Claude rather than out of you, rewrite it first — that is the one part of an ADR that cannot be delegated.</a:t>
             </a:r>
           </a:p>
         </p:txBody>
@@ -22586,7 +22586,7 @@
                 </a:solidFill>
                 <a:latin typeface="Arial"/>
               </a:rPr>
-              <a:t>Same clause list, different documents — what did each choose to check, and what did they mark?</a:t>
+              <a:t>Same clause list, different documents — screen-share each: what did they choose to check, and what did they mark?</a:t>
             </a:r>
           </a:p>
           <a:p>
@@ -22623,7 +22623,7 @@
                 </a:solidFill>
                 <a:latin typeface="Arial"/>
               </a:rPr>
-              <a:t>What was hard, what was easy? Thirty seconds each, around the room.</a:t>
+              <a:t>What was hard, what was easy? One line each in chat, waterfall style.</a:t>
             </a:r>
           </a:p>
           <a:p>

</xml_diff>

<commit_message>
update to be less group and more individuial and addeed a second demo walkthrough
</commit_message>
<xml_diff>
--- a/docs/instructor/lab-2a-writing-the-standards-down.pptx
+++ b/docs/instructor/lab-2a-writing-the-standards-down.pptx
@@ -1231,7 +1231,7 @@
           <a:lstStyle/>
           <a:p>
             <a:r>
-              <a:t>[CALIBRATED from Lab 1.b, 2026-08-12: agenda held · prompting depth right · checkpoint gates worked · mostly solo, fine · room waits to be told → 4 seed clauses + 10-min derive] Scaffolding drops here — from following along to deciding. Announce the mode change explicitly; it should not be discovered. Say what the next 40 minutes look like in one breath: read three fixes (4 min, silent) -&gt; in groups, turn four seed clauses into your rule (10 min, structured — the clock slide gives the shape) -&gt; we agree one list as a room (4 min) -&gt; each of you writes it up as YOUR OWN NFR (20 min). Nobody is graded on the discussion; everybody ships a document. Full teaching guide for this block — run sheet, scripts, expected-clause bank, recoveries: docs/instructor/lab-2a-derive-teachers-guide.md.</a:t>
+              <a:t>[CALIBRATED from Lab 1.b, 2026-08-12: agenda held · prompting depth right · checkpoint gates worked · mostly solo, fine · room waits to be told → 4 seed clauses + 10-min derive] Scaffolding drops here — from following along to deciding. Announce the mode change explicitly; it should not be discovered. Say what the next 40 minutes look like in one breath: read three fixes (4 min, silent) -&gt; ON YOUR OWN, turn four seed clauses into your rule (10 min, structured — the clock slide gives the shape) -&gt; we compare lists and agree one as a class (4 min) -&gt; each of you writes it up as YOUR OWN NFR (20 min). Individual by design — this course must also work self-guided; the class compare is calibration, not committee work. Full teaching guide for this block — run sheet, scripts, expected-clause bank, recoveries: docs/instructor/lab-2a-derive-teachers-guide.md.</a:t>
             </a:r>
           </a:p>
         </p:txBody>
@@ -1441,7 +1441,7 @@
           <a:lstStyle/>
           <a:p>
             <a:r>
-              <a:t>Present this in ONE minute, then start the clock and circulate — the structure is the mitigation for a room that waits to be told. The catch-test ("which of A/B/C does this clause catch?") replaces a devil's-advocate role: it is self-administering, and any group that runs it honestly discovers that "ships with a test" does not catch B — which is the discovery the exercise exists for. COMMON QUESTIONS — Q: "What does mechanical mean, exactly?" A: a script, given ONLY the diff, could return pass/fail — if you need to know intent, it's fuzzy. Q: "Can a clause be conditional?" A: yes — "docs-only changes are exempt" is a fine clause, and note it: that exemption becomes a CI path filter next week. Q: "What if we all just agree?" A: run the catch-test out loud — which fix does each kept clause catch? If nothing on your list catches B, you are not done. Q: "Does wording matter?" A: substance now, wording when you write the NFR — the group list are raw material, not the document. ~1 min to present.</a:t>
+              <a:t>Present this in ONE minute, then start the clock and circulate — the structure is the mitigation for a cohort that waits to be told — and the INDIVIDUAL shape is deliberate: this course must survive becoming self-guided, and independent verdicts beat one early consensus. The catch-test ("which of A/B/C does this clause catch?") is self-administering: anyone who runs it honestly discovers that "ships with a test" does not catch B — the discovery the exercise exists for. COMMON QUESTIONS — Q: "What does mechanical mean, exactly?" A: a script, given ONLY the diff, could return pass/fail — if you need to know intent, it's fuzzy. Q: "Can a clause be conditional?" A: yes — "docs-only changes are exempt" is a fine clause, and note it: that exemption becomes a CI path filter next week. Q: "What if we all just agree?" A: run the catch-test out loud — which fix does each kept clause catch? If nothing on your list catches B, you are not done. Q: "Does wording matter?" A: substance now, wording when you write the NFR — the Doc list are raw material, not the document. ~1 min to present.</a:t>
             </a:r>
           </a:p>
         </p:txBody>
@@ -1511,7 +1511,7 @@
           <a:lstStyle/>
           <a:p>
             <a:r>
-              <a:t>[CALIBRATED from Lab 1.b, 2026-08-12: agenda held · prompting depth right · checkpoint gates worked · mostly solo, fine · room waits to be told → 4 seed clauses + 10-min derive] Ten minutes, tight — 1.b says this room waits to be told, so drive it: the FACILITATION LADDER, in order, per stalled group: (1) "Seed 2 — keep, tighten, or drop?" (2) "Fix B is green. Would seed 1 alone have caught it?" (3) "Which of your tags could a script actually decide — prove it: what does the script read?" Never state a clause yourself. Watch for the room deciding B is acceptable; that is the interesting case — do NOT tell them. Group B keeps faster tables on the second convention; its output feeds the merge. Point back at the clock slide when a group drifts. ~10 min.</a:t>
+              <a:t>[CALIBRATED from Lab 1.b, 2026-08-12: agenda held · prompting depth right · checkpoint gates worked · mostly solo, fine · room waits to be told → 4 seed clauses + 10-min derive] Ten minutes, silent, individual — mics muted, monitor the Doc as lists appear. 1.b says this cohort waits to be told, so the ladder is delivered as TIMED CHAT NUDGES to everyone, not as visits: at ~3 min, "Seed 2 — keep, tighten, or drop?"; at ~6, "Fix B is green. Would seed 1 alone have caught it?"; at ~8, "Which of your tags could a script actually decide?" Never state a clause. Individuals stuck beyond the nudges get a Slack ping, not a call-out. Watch the Doc for lists where B passes — the interesting case; do NOT flag it yet. Fast finishers: the store boundary, same method, as stretch. ~10 min.</a:t>
             </a:r>
           </a:p>
         </p:txBody>
@@ -1581,7 +1581,7 @@
           <a:lstStyle/>
           <a:p>
             <a:r>
-              <a:t>[CALIBRATED from Lab 1.b, 2026-08-12: agenda held · prompting depth right · checkpoint gates worked · mostly solo, fine · room waits to be told → 4 seed clauses + 10-min derive] MANDATORY: state and write the agreed clauses before advancing — an unresolved discussion is worse than none. Run it as: each group reads its biggest disagreement first (that is why they picked one), THEN the lists. Card contents are illustrative; replace live with what the room produced. If they missed "failed first", ask: "B was green before the fix. Would your rule have caught it?" Apply the tiebreak out loud when groups conflict: the stricter clause wins unless someone can show it false-positives on real code in this repo. COMMON QUESTIONS — Q: "Who owns this agreed list?" A: the room does, as of now — it goes in everyone's NFR; a champion owns keeping it true after today. Q: "Group A and B derived different rules — which is THE standard?" A: both — test discipline and the store boundary are two NFRs; you write up your group's. Q: "Can we change the list later?" A: yes — NFRs revise in place; that is the lifecycle slide made real. ARTIFACT BEAT (30 sec, do not skip): ask "which artifact is this list?" and give ten seconds before answering — someone will say ADR, and that is the productive mistake: it FEELS like a decision, but the quick test says NFR (always-holds + checkable; present tense; revised in place). If adopting the rule ever becomes genuinely contested, THAT argument earns an ADR. And the know-how ("how do I write a failing test first?") is recipe material — a stretch, not today. One derivation, three artifact homes — the slide-6 skill, used on their own work. "The test failed first" is the clause that matters most, and no gate can decide it — that is the finding, and 2.b's opening problem. ~3 min.</a:t>
+              <a:t>[CALIBRATED from Lab 1.b, 2026-08-12: agenda held · prompting depth right · checkpoint gates worked · mostly solo, fine · room waits to be told → 4 seed clauses + 10-min derive] MANDATORY: state and write the agreed clauses before advancing — an unresolved compare is worse than none. Run it as: share the Doc on screen, name the clauses MOST lists agree on (those enter AGREED fast), then ask two or three people to unmute and read their LEAST-SURE clause (that is why they marked one) — divergence is where the standard gets made. Card contents are illustrative; replace live with what the room produced. If they missed "failed first", ask: "B was green before the fix. Would your rule have caught it?" Apply the tiebreak out mic when lists conflict: the stricter clause wins unless someone can show it false-positives on real code in this repo. COMMON QUESTIONS — Q: "Who owns this agreed list?" A: the class does, as of now — it goes in everyone's NFR; a champion owns keeping it true after today. Q: "My list disagrees with AGREED — do I write mine or ours?" A: ours — AGREED is the standard; record your dissent as a dropped clause with a reason, which is exactly how disagreement with a live standard works on a real team. Q: "Can we change the list later?" A: yes — NFRs revise in place; that is the lifecycle slide made real. ARTIFACT BEAT (30 sec, do not skip): ask "which artifact is this list?" and give ten seconds before answering — someone will say ADR, and that is the productive mistake: it FEELS like a decision, but the quick test says NFR (always-holds + checkable; present tense; revised in place). If adopting the rule ever becomes genuinely contested, THAT argument earns an ADR. And the know-how ("how do I write a failing test first?") is recipe material — a stretch, not today. One derivation, three artifact homes — the slide-6 skill, used on their own work. "The test failed first" is the clause that matters most, and no gate can decide it — that is the finding, and 2.b's opening problem. ~3 min.</a:t>
             </a:r>
           </a:p>
         </p:txBody>
@@ -1791,7 +1791,7 @@
           <a:lstStyle/>
           <a:p>
             <a:r>
-              <a:t>[CALIBRATED from Lab 1.b, 2026-08-12: agenda held · prompting depth right · checkpoint gates worked · mostly solo, fine · room waits to be told → 4 seed clauses + 10-min derive] Circulate with one question per group: "how is that checked?" If they cannot answer, the clause is not finished. The skeleton on screen is also in the handout. Reserve the last five minutes for peer review — it is an acceptance criterion and the first thing skipped. COMMON QUESTIONS — Q: "We derived as a group — does everyone write the same NFR?" A: same clauses, YOUR document: your wording, your Checked-by lines, your marks; the peer review is what catches where wording changed the meaning. Q: "What filename?" A: docs/nfr/0002-test-discipline.md (group B: 0002-db-access-boundary.md) — next number, kebab-case, like the ADR. Q: "Do dropped clauses go in?" A: yes, one line each at the bottom with the drop decision and a name — a visibly-considered-and-dropped clause stops the same debate re-running next quarter. Q: "How formal is the wording?" A: NFR-0001's tone: plain sentences, numbered, no legalese — the Checked-by line is where the rigour lives. ~20 min.</a:t>
+              <a:t>[CALIBRATED from Lab 1.b, 2026-08-12: agenda held · prompting depth right · checkpoint gates worked · mostly solo, fine · room waits to be told → 4 seed clauses + 10-min derive] One recurring chat nudge: "how is that clause checked?" If someone cannot answer, the clause is not finished. The skeleton on screen is also in the handout. Reserve the last five minutes for peer review — it is an acceptance criterion and the first thing skipped. COMMON QUESTIONS — Q: "We all start from the same AGREED list — does everyone write the same NFR?" A: same clauses, YOUR document: your wording, your Checked-by lines, your marks, your dropped-clause dissents; the peer review is what catches where wording changed the meaning. Q: "What filename?" A: docs/nfr/0002-test-discipline.md — next number, kebab-case, like the ADR (the store-boundary stretch would be 0003). Q: "Do dropped clauses go in?" A: yes, one line each at the bottom with the drop decision and a name — a visibly-considered-and-dropped clause stops the same debate re-running next quarter. Q: "How formal is the wording?" A: NFR-0001's tone: plain sentences, numbered, no legalese — the Checked-by line is where the rigour lives. ~20 min.</a:t>
             </a:r>
           </a:p>
         </p:txBody>
@@ -1861,7 +1861,7 @@
           <a:lstStyle/>
           <a:p>
             <a:r>
-              <a:t>[CALIBRATED from Lab 1.b, 2026-08-12: agenda held · prompting depth right · checkpoint gates worked · mostly solo, fine · room waits to be told → 4 seed clauses + 10-min derive] Ask one voice per group to unmute and read a fuzzy clause with its recorded decision — two minutes, and it makes the standard real. The common failure here: a "Checked by: code review" line on every clause — that is the human gate as a reflex, not a decision; push once: "could a script check THIS one?" Fast finishers: the half-gate stretch (write the ESLint clause) or the rules-file conversion. ~2 min.</a:t>
+              <a:t>[CALIBRATED from Lab 1.b, 2026-08-12: agenda held · prompting depth right · checkpoint gates worked · mostly solo, fine · room waits to be told → 4 seed clauses + 10-min derive] Ask two or three people to unmute and read a fuzzy clause with its recorded decision — two minutes, and it makes the standard real. The common failure here: a "Checked by: code review" line on every clause — that is the human gate as a reflex, not a decision; push once: "could a script check THIS one?" Fast finishers: the half-gate stretch (write the ESLint clause) or the rules-file conversion. ~2 min.</a:t>
             </a:r>
           </a:p>
         </p:txBody>
@@ -11760,7 +11760,7 @@
                 </a:solidFill>
                 <a:latin typeface="Arial"/>
               </a:rPr>
-              <a:t>The clause list later is group work. Every document today is yours, in your copy.</a:t>
+              <a:t>Everything today is yours, in your copy — including the clause list you derive later.</a:t>
             </a:r>
           </a:p>
         </p:txBody>
@@ -15344,7 +15344,7 @@
                 </a:solidFill>
                 <a:latin typeface="Arial"/>
               </a:rPr>
-              <a:t>0–1</a:t>
+              <a:t>0–4</a:t>
             </a:r>
           </a:p>
         </p:txBody>
@@ -15386,7 +15386,7 @@
                 </a:solidFill>
                 <a:latin typeface="Arial"/>
               </a:rPr>
-              <a:t>Pick who writes</a:t>
+              <a:t>Verdict each seed: keep, tighten, or drop. A clause earns KEEP only if you can name which of A / B / C it catches</a:t>
             </a:r>
           </a:p>
         </p:txBody>
@@ -15428,7 +15428,7 @@
                 </a:solidFill>
                 <a:latin typeface="Arial"/>
               </a:rPr>
-              <a:t>One list everyone can see — talk without writing leaves nothing to merge</a:t>
+              <a:t>Four verdicts, each tagged MECHANICAL or FUZZY</a:t>
             </a:r>
           </a:p>
         </p:txBody>
@@ -15514,7 +15514,7 @@
                 </a:solidFill>
                 <a:latin typeface="Arial"/>
               </a:rPr>
-              <a:t>1–5</a:t>
+              <a:t>4–7</a:t>
             </a:r>
           </a:p>
         </p:txBody>
@@ -15556,7 +15556,7 @@
                 </a:solidFill>
                 <a:latin typeface="Arial"/>
               </a:rPr>
-              <a:t>Verdict each seed: keep, tighten, or drop. A clause earns KEEP only if you can name which of A / B / C it catches</a:t>
+              <a:t>Add your own clauses — what did the seeds miss?</a:t>
             </a:r>
           </a:p>
         </p:txBody>
@@ -15598,7 +15598,7 @@
                 </a:solidFill>
                 <a:latin typeface="Arial"/>
               </a:rPr>
-              <a:t>Four verdicts, each tagged MECHANICAL or FUZZY</a:t>
+              <a:t>One or two more, tagged. More than 6 total means they're too small</a:t>
             </a:r>
           </a:p>
         </p:txBody>
@@ -15684,7 +15684,7 @@
                 </a:solidFill>
                 <a:latin typeface="Arial"/>
               </a:rPr>
-              <a:t>5–8</a:t>
+              <a:t>7–9</a:t>
             </a:r>
           </a:p>
         </p:txBody>
@@ -15726,7 +15726,7 @@
                 </a:solidFill>
                 <a:latin typeface="Arial"/>
               </a:rPr>
-              <a:t>Add your own clauses — what did the seeds miss?</a:t>
+              <a:t>Mark the one clause you're LEAST sure about</a:t>
             </a:r>
           </a:p>
         </p:txBody>
@@ -15768,7 +15768,7 @@
                 </a:solidFill>
                 <a:latin typeface="Arial"/>
               </a:rPr>
-              <a:t>One or two more, tagged. More than 6 total means they're too small</a:t>
+              <a:t>That is what you'll raise at the compare — doubt is the interesting output</a:t>
             </a:r>
           </a:p>
         </p:txBody>
@@ -15854,7 +15854,7 @@
                 </a:solidFill>
                 <a:latin typeface="Arial"/>
               </a:rPr>
-              <a:t>8–10</a:t>
+              <a:t>9–10</a:t>
             </a:r>
           </a:p>
         </p:txBody>
@@ -15896,7 +15896,7 @@
                 </a:solidFill>
                 <a:latin typeface="Arial"/>
               </a:rPr>
-              <a:t>Pick your one biggest disagreement</a:t>
+              <a:t>Paste your list into the shared Doc, under your name</a:t>
             </a:r>
           </a:p>
         </p:txBody>
@@ -15938,7 +15938,7 @@
                 </a:solidFill>
                 <a:latin typeface="Arial"/>
               </a:rPr>
-              <a:t>You'll say it out loud in the merge — disagreement is the interesting output</a:t>
+              <a:t>Everyone's lists, side by side — the raw material for the class standard</a:t>
             </a:r>
           </a:p>
         </p:txBody>
@@ -15980,7 +15980,7 @@
                 </a:solidFill>
                 <a:latin typeface="Arial"/>
               </a:rPr>
-              <a:t>The clause list is the only group output. Everything graded — the NFR you write next — is yours alone, in your own copy, through your own PR. (And: tighten = more checkable, not more strict.)</a:t>
+              <a:t>All of it is yours: this list, and the NFR you write from it — your own copy, your own PR. The class compare that follows is calibration, not a committee. (And: tighten = more checkable, not more strict.)</a:t>
             </a:r>
           </a:p>
         </p:txBody>
@@ -16230,7 +16230,7 @@
                 </a:solidFill>
                 <a:latin typeface="Arial"/>
               </a:rPr>
-              <a:t>Ten minutes, in groups, on the clock you just saw: verdict each seed (keep / tighten / drop), tag it, add your own. These clauses become the Rules section of your NFR.</a:t>
+              <a:t>Ten minutes, on your own, on the clock you just saw: verdict each seed (keep / tighten / drop), tag it, add your own. These clauses become the Rules section of your NFR.</a:t>
             </a:r>
           </a:p>
         </p:txBody>
@@ -16901,7 +16901,7 @@
                 </a:solidFill>
                 <a:latin typeface="Arial"/>
               </a:rPr>
-              <a:t>TWO GROUPS</a:t>
+              <a:t>THEN THE COMPARE</a:t>
             </a:r>
           </a:p>
         </p:txBody>
@@ -16952,7 +16952,7 @@
                 </a:solidFill>
                 <a:latin typeface="Arial"/>
               </a:rPr>
-              <a:t>A: test discipline (these diffs)</a:t>
+              <a:t>Paste your list in the Doc, under your name</a:t>
             </a:r>
           </a:p>
           <a:p>
@@ -16980,7 +16980,7 @@
                 </a:solidFill>
                 <a:latin typeface="Arial"/>
               </a:rPr>
-              <a:t>B: the store boundary (imports of db/store.ts)</a:t>
+              <a:t>The class agrees ONE list from them</a:t>
             </a:r>
           </a:p>
           <a:p>
@@ -17008,7 +17008,7 @@
                 </a:solidFill>
                 <a:latin typeface="Arial"/>
               </a:rPr>
-              <a:t>Same job: clauses, tagged</a:t>
+              <a:t>Stretch: the store boundary, same method</a:t>
             </a:r>
           </a:p>
         </p:txBody>
@@ -17258,7 +17258,7 @@
                 </a:solidFill>
                 <a:latin typeface="Arial"/>
               </a:rPr>
-              <a:t>Written down before anyone moves on. This is the agreed list, not my list.</a:t>
+              <a:t>Your lists, side by side in the Doc — now the class agrees ONE. Written down before anyone moves on.</a:t>
             </a:r>
           </a:p>
         </p:txBody>
@@ -18050,7 +18050,7 @@
                 </a:solidFill>
                 <a:latin typeface="Arial"/>
               </a:rPr>
-              <a:t>Which of the five artifacts is this list? Apply the quick test: must always hold, and you can say how it is checked → an NFR. It feels decision-ish — but it is present-tense law, revised in place. Tiebreak when groups conflict: the stricter clause wins unless someone shows it false-positives on real code here.</a:t>
+              <a:t>Which of the five artifacts is this list? Apply the quick test: must always hold, and you can say how it is checked → an NFR. It feels decision-ish — but it is present-tense law, revised in place. Tiebreak when lists conflict: the stricter clause wins unless someone shows it false-positives on real code here.</a:t>
             </a:r>
           </a:p>
         </p:txBody>

</xml_diff>

<commit_message>
cleaning up the notes for the deck
</commit_message>
<xml_diff>
--- a/docs/instructor/lab-2a-writing-the-standards-down.pptx
+++ b/docs/instructor/lab-2a-writing-the-standards-down.pptx
@@ -1651,7 +1651,7 @@
           <a:lstStyle/>
           <a:p>
             <a:r>
-              <a:t>Two minutes, and it is the hinge: written-unchecked, checked, half-checked all live in ONE file the room already trusts. The half-gate case is the stretch item — closing it is an ESLint rule away. This is Appendix C's logging-standards coverage: the convention exists; the class derives what checking it would mean. ~2 min.</a:t>
+              <a:t>THE GOAL OF THIS SLIDE, in one sentence: prove that the MECHANICAL/FUZZY tag they just put on their own clauses is not homework bookkeeping — it is a property every written rule already has, demonstrated in a file they already trust. Same CLAUDE.md, three rules, three enforcement states: the store boundary is WRITTEN and nothing checks it (their morning ADR subject — a rule can be documented and still be only a promise); console.log is CHECKED (lint fails it — the only one of the three that is actually a gate); logger.info with a wrong first arg is HALF-CHECKED — it looks enforced, passes silently, and that false confidence makes the half-gate the most dangerous state of the three, worse than unchecked because nobody is watching a rule they believe a machine watches. The three states are NAMED on the slide — walk them top to bottom, then land the last bullet as the bridge to the write-up: the Checked-by line is where each clause's state gets RECORDED, and 2.b is where the unchecked ones get teeth. If you want a discussion beat, ask "so which of these is a standard?" and answer it: all three (written + agreed) — what differs is only how much of each is backed by a check. FACT-CHECKED against the repo 2026-08-13: the shown call keeps the signature (scope, message, meta) typed correctly, so tsc passes it AND eslint passes it — only the CONVENTION (scope = file basename) is violated, and nothing checks that. Say the strengthened version out loud: TWO machine checkers watch this exact line, and the rule still slips through, because neither was aimed at it. This slide is a taught exhibit, NOT an exercise — do not invite a live paste-test. COMMON QUESTIONS — Q: "I tried a wrong first arg and the editor DID flag it" A: almost certainly the TYPE checker, because the pasted call dropped the message argument — a shape error, not the convention; keep all three args typed right and every checker goes quiet. And that near-miss IS the lesson: an error NEAR a rule reads as enforcement of the rule, which is how half-gates stay invisible. Q: "What is meta?" A: the optional third argument — a plain object of structured context (Record&lt;string, unknown&gt;) that the logger JSON-stringifies onto the log line; the ? means optional, borrowed from TypeScript. VALID (all pass tsc): logger.info('todos.service', 'created', { id }) — object literal in the third slot; logger.info('http', 'GET /api/todos 200', { durationMs }) — the live call in requestLogger.ts; logger.info('index', 'server started') — meta omitted entirely, that is what optional means. INVALID (each verified against tsc 2026-08-13): logger.info('todos.service', { id }) — only two args, so the object sits in the MESSAGE slot, which must be a string (the classic mistake); logger.info('todos.service', 'created', 'id=' + id) — meta must be an object, never a pre-formatted string: put values IN the object; logger.info('todos.service', 'created', id) — a bare value is not a Record: wrap it as { id }. Rule of thumb: two strings, then one object or nothing. Q: "Isn't the scope convention FUZZY, then — nothing checks it?" A: no — unchecked and UNCHECKABLE are different facts. CAN a machine check it? Yes: the linter always knows which file it is in, so a rule comparing the first-arg literal to the file basename is a dumb string comparison — MECHANICAL. DOES anything check it today? No — nobody wrote that rule. Checkable-but-unchecked is exactly what a half-gate is. Contrast: "the test failed before the fix" is UNCHECKABLE from the code — that one is fuzzy. (Full honesty for a sharp room: a variable first arg defeats the literal comparison, so strictly the clause is PARTLY — 2.b names that tier.) Q: "So is the logging rule enforced or not?" A: half — the channel is enforced, the content is not; "enforced" is per-CLAUSE, never per-rule, which is why your NFR marks each clause separately. Q: "Why not just fix the half-gate now?" A: it is an ESLint rule away and makes a fine stretch — but today the point is SEEING the state, not fixing it; you will close a gap like this in 2.b. ~2 min.</a:t>
             </a:r>
           </a:p>
         </p:txBody>
@@ -1931,7 +1931,7 @@
           <a:lstStyle/>
           <a:p>
             <a:r>
-              <a:t>Name the two mechanisms out loud — trigger row vs binding line — and anchor both in 1.a: the trigger row is the lazy pointer they already know; the binding line is a deliberate eager load, kept to one sentence precisely because eager costs every session. The binding line is new vocabulary and it is graded. NFR-0001 has no binding line yet; they are setting the pattern. The smoke test takes 60 seconds: new session, ask the rule, watch whether it reads the doc or guesses. If it guesses, the trigger is phrased as a topic, not a situation — fixable in one edit. ~9 min.</a:t>
+              <a:t>The slide before showed WHAT the two entries are; this one says what each DOES — same rule, referenced twice, two different jobs. Say the mechanics precisely. The BINDING LINE enforces by PRESENCE: it is the rule's one operative sentence living inside CLAUDE.md, so it is in context every session — loaded once with the file, no separate fetch, and above all no DECISION: the trigger row works only if Claude correctly decides the situation applies; the binding line arrives whether or not anything decides anything. SAY THE WORD OUT LOUD BEFORE THE ROOM MISREADS IT: binding as in a binding CONTRACT — the line is the rule, in force — NOT binding as in data-binding; it does not wire anything to anything, and its citation loads nothing. Developers reliably hear the wrong one first. The TRIGGER ROW, by contrast, has two parts and naming them helps: a SITUATION ("when you are fixing a bug") and a POINTER ("read docs/nfr/0002 first") — the pointer gives Claude the ABILITY to load the full doc; the situation says WHEN to use it. (Precision for the sharp student: CLAUDE.md itself IS read at session start — the claim is not "never loaded", it is "never conditional".) Its (NFR-0002) tail is a CITATION, not a loader: it tells Claude and humans where the full law lives, one deliberate hop away. The TRIGGER ROW loads by SITUATION: when the task matches "fixing a bug or adding behaviour", Claude goes and reads the whole NFR — every clause, Checked-by line, dropped clause. TWO PATHS to the full document, and only one is designed: (1) the trigger row — the situation matches, the doc is read; this is the reliable path. (2) following the citation — Claude (or a person) mid-task decides it needs more than the headline and chases NFR-0002; possible because the citation exists, but voluntary — nothing forces it. Delete the trigger row and path 2 still exists, but now you are relying on Claude spontaneously deciding to look things up — hope-based governance, the exact thing this lab replaces. Anchor in 1.a: the trigger row is the lazy pointer they already know; the binding line is a deliberate one-line eager load, kept to one sentence precisely because eager space is paid every session. Kill each one mentally to prove both are needed: no binding line, and the always-applies rule hangs on Claude deciding to fetch; no trigger row, and the details (how each clause is checked, the exceptions) are unreachable by situation. The binding line is new vocabulary and it is graded. WHEN IS A BINDING LINE NEEDED — give them the test, then the repo's own contrast: ask "in what situation does this rule apply?" If you can name one narrower than ANY CHANGE, the trigger row is enough — that is why NFR-0001 needs NO binding line: "calling an external API" is a nameable situation, so its trigger row suffices. Test discipline applies to every change — no situation could trigger the fetch reliably — so it is the first rule in this repo that EARNS the eager line. Expect binding lines to stay RARE: a CLAUDE.md full of them is just a second copy of every document — one or two in a healthy file. COMMON QUESTIONS — Q: "Why not just make the binding line say READ docs/nfr/0002 before any change?" A: three reasons. One: that converts a one-line cost into a full-document fetch on every session, to retrieve a rule whose operative sentence fits in one line. Two: "always read X first" is the weakest kind of instruction — under pressure it gets skipped, while a rule stated in place is simply THERE; the sign on the wall works because it IS the rule, not directions to the rulebook. Three: the binding line already cites NFR-0002, so the full law — all clauses, Checked-by lines, dropped clauses — is one hop away when nuance is needed. Q: "Then why not paste the whole NFR into CLAUDE.md?" A: one home per fact — a copy drifts from the doc and then nobody knows which is authoritative; and CLAUDE.md is a paid-every-session index, not a library. Q: "The trigger row already says fixing-a-bug -&gt; read the NFR — is the binding line not redundant?" A: the trigger is a fetch DECISION Claude makes each time, and a rule that applies to every change would need that decision made right every time; the binding line is deterministic presence. Redundant on purpose — like the deny rule and the hook next week. Q: "Why doesn't the binding line load the NFR when I am fixing a bug?" A: nothing in CLAUDE.md EXECUTES — every entry is a sentence Claude obeys, and each does exactly what its text says: "Read first: docs/nfr/0002" instructs a read, "ships with a test" instructs a test. The load while bug-fixing comes from the trigger row, the only sentence that says READ. Q: "Is the trigger row enforced?" A: no — all of this wiring is layer 1, instruction; nothing verifies the read happened, and the smoke test is a manual probe, not a gate. Next week does NOT change that: 2.b enforces the OUTCOME (a test in the diff, via hook + CI gate), never the reading — you cannot usefully gate "did the model read the doc", you gate the consequence, and once the outcome is gated the read matters less. Layer 1 informs; layers 2–4 enforce. The smoke test takes 60 seconds: new session, ask the rule, watch whether it reads the doc or guesses. If it guesses, the trigger is phrased as a topic, not a situation — fixable in one edit. ~9 min.</a:t>
             </a:r>
           </a:p>
         </p:txBody>
@@ -18300,7 +18300,7 @@
                 </a:solidFill>
                 <a:latin typeface="Arial"/>
               </a:rPr>
-              <a:t>A rule with half a gate. Your NFR clauses will have the same three states — that is what the tag is for.</a:t>
+              <a:t>The lesson: WRITTEN and ENFORCED are different properties of a rule. Three rules from the CLAUDE.md you already trust — one in each state.</a:t>
             </a:r>
           </a:p>
         </p:txBody>
@@ -18378,7 +18378,7 @@
                 </a:solidFill>
                 <a:latin typeface="Arial"/>
               </a:rPr>
-              <a:t>ONE CLAUDE.MD, THREE RULES</a:t>
+              <a:t>ONE CLAUDE.MD, THREE RULES — ONE RULE IN EACH STATE</a:t>
             </a:r>
           </a:p>
         </p:txBody>
@@ -18429,7 +18429,7 @@
                 </a:solidFill>
                 <a:latin typeface="Arial"/>
               </a:rPr>
-              <a:t>Store boundary: written, NOTHING checks it.</a:t>
+              <a:t>WRITTEN ONLY — the store boundary: nothing checks it. A promise.</a:t>
             </a:r>
           </a:p>
           <a:p>
@@ -18457,7 +18457,7 @@
                 </a:solidFill>
                 <a:latin typeface="Arial"/>
               </a:rPr>
-              <a:t>console.log in server/src: lint FAILS it.</a:t>
+              <a:t>CHECKED — console.log: lint fails it. A gate.</a:t>
             </a:r>
           </a:p>
           <a:p>
@@ -18485,7 +18485,7 @@
                 </a:solidFill>
                 <a:latin typeface="Arial"/>
               </a:rPr>
-              <a:t>logger.info with a wrong first arg: passes SILENTLY.</a:t>
+              <a:t>HALF-CHECKED — logger.info with a message where the file basename belongs: types pass, lint passes. The dangerous one — it LOOKS enforced.</a:t>
             </a:r>
           </a:p>
           <a:p>
@@ -18513,7 +18513,7 @@
                 </a:solidFill>
                 <a:latin typeface="Arial"/>
               </a:rPr>
-              <a:t>Which of these is a standard? Why?</a:t>
+              <a:t>Every clause you just tagged sits in one of these states. The Checked-by line in your NFR records which.</a:t>
             </a:r>
           </a:p>
         </p:txBody>
@@ -18640,7 +18640,7 @@
                 </a:solidFill>
                 <a:latin typeface="Arial"/>
               </a:rPr>
-              <a:t>SERVER/SRC — TRY IT</a:t>
+              <a:t>THE EVIDENCE — EVERY CHECKER'S VERDICT, PER CALL</a:t>
             </a:r>
           </a:p>
         </p:txBody>
@@ -18777,7 +18777,7 @@
                 </a:solidFill>
                 <a:latin typeface="Consolas"/>
               </a:rPr>
-              <a:t>  // -&gt; lint error. CAUGHT.</a:t>
+              <a:t>// LINT ERROR (no-console).</a:t>
             </a:r>
           </a:p>
           <a:p>
@@ -18796,6 +18796,25 @@
                 </a:solidFill>
                 <a:latin typeface="Consolas"/>
               </a:rPr>
+              <a:t>// The channel is CHECKED.</a:t>
+            </a:r>
+          </a:p>
+          <a:p>
+            <a:pPr algn="l">
+              <a:lnSpc>
+                <a:spcPct val="114000"/>
+              </a:lnSpc>
+              <a:spcAft>
+                <a:spcPts val="0"/>
+              </a:spcAft>
+            </a:pPr>
+            <a:r>
+              <a:rPr sz="900" b="0">
+                <a:solidFill>
+                  <a:srgbClr val="434343"/>
+                </a:solidFill>
+                <a:latin typeface="Consolas"/>
+              </a:rPr>
               <a:t/>
             </a:r>
           </a:p>
@@ -18834,7 +18853,7 @@
                 </a:solidFill>
                 <a:latin typeface="Consolas"/>
               </a:rPr>
-              <a:t>  { id })</a:t>
+              <a:t>  'created', { id })</a:t>
             </a:r>
           </a:p>
           <a:p>
@@ -18853,7 +18872,7 @@
                 </a:solidFill>
                 <a:latin typeface="Consolas"/>
               </a:rPr>
-              <a:t>  // wrong first arg -&gt; passes.</a:t>
+              <a:t>// tsc: clean. eslint: clean.</a:t>
             </a:r>
           </a:p>
           <a:p>
@@ -18872,7 +18891,26 @@
                 </a:solidFill>
                 <a:latin typeface="Consolas"/>
               </a:rPr>
-              <a:t>  // HALF a gate.</a:t>
+              <a:t>// The scope convention is</a:t>
+            </a:r>
+          </a:p>
+          <a:p>
+            <a:pPr algn="l">
+              <a:lnSpc>
+                <a:spcPct val="114000"/>
+              </a:lnSpc>
+              <a:spcAft>
+                <a:spcPts val="0"/>
+              </a:spcAft>
+            </a:pPr>
+            <a:r>
+              <a:rPr sz="900" b="0">
+                <a:solidFill>
+                  <a:srgbClr val="434343"/>
+                </a:solidFill>
+                <a:latin typeface="Consolas"/>
+              </a:rPr>
+              <a:t>// checked by NOTHING.</a:t>
             </a:r>
           </a:p>
         </p:txBody>
@@ -21538,7 +21576,7 @@
                 </a:solidFill>
                 <a:latin typeface="Arial"/>
               </a:rPr>
-              <a:t>A document nothing points at is a document nobody reads</a:t>
+              <a:t>A doc nothing points at is a doc nobody reads</a:t>
             </a:r>
           </a:p>
         </p:txBody>
@@ -21658,7 +21696,7 @@
                 </a:solidFill>
                 <a:latin typeface="Arial"/>
               </a:rPr>
-              <a:t>TWO KINDS OF WIRING</a:t>
+              <a:t>THE SAME RULE, WIRED TWICE — TWO DIFFERENT JOBS</a:t>
             </a:r>
           </a:p>
         </p:txBody>
@@ -21709,7 +21747,7 @@
                 </a:solidFill>
                 <a:latin typeface="Arial"/>
               </a:rPr>
-              <a:t>A TRIGGER ROW per doc — fetches the full doc when the situation applies.</a:t>
+              <a:t>BINDING LINE — enforces by PRESENCE: it IS the rule's headline sentence, riding in with CLAUDE.md every session. No fetch DECISION.</a:t>
             </a:r>
           </a:p>
           <a:p>
@@ -21737,7 +21775,7 @@
                 </a:solidFill>
                 <a:latin typeface="Arial"/>
               </a:rPr>
-              <a:t>A BINDING LINE for the NFR — one line, always in force, never fetched.</a:t>
+              <a:t>TRIGGER ROW — a SITUATION ("when you are…") plus a POINTER ("read first"): the situation says when, the pointer loads the FULL doc.</a:t>
             </a:r>
           </a:p>
           <a:p>
@@ -21765,7 +21803,7 @@
                 </a:solidFill>
                 <a:latin typeface="Arial"/>
               </a:rPr>
-              <a:t>Same pair as 1.a: trigger row = the lazy pointer; binding line = a one-line EAGER load.</a:t>
+              <a:t>When does a rule EARN a binding line? Name its situation. Specific ("calling an external API") — trigger row only. "Every change" — binding line.</a:t>
             </a:r>
           </a:p>
           <a:p>
@@ -21793,35 +21831,7 @@
                 </a:solidFill>
                 <a:latin typeface="Arial"/>
               </a:rPr>
-              <a:t>The doc is the law; the binding line is the sign on the wall.</a:t>
-            </a:r>
-          </a:p>
-          <a:p>
-            <a:pPr algn="l">
-              <a:lnSpc>
-                <a:spcPct val="120000"/>
-              </a:lnSpc>
-              <a:spcAft>
-                <a:spcPts val="800"/>
-              </a:spcAft>
-            </a:pPr>
-            <a:r>
-              <a:rPr sz="1100" b="1">
-                <a:solidFill>
-                  <a:srgbClr val="A9B7F7"/>
-                </a:solidFill>
-                <a:latin typeface="Arial"/>
-              </a:rPr>
-              <a:t>•  </a:t>
-            </a:r>
-            <a:r>
-              <a:rPr sz="1100" b="0">
-                <a:solidFill>
-                  <a:srgbClr val="434343"/>
-                </a:solidFill>
-                <a:latin typeface="Arial"/>
-              </a:rPr>
-              <a:t>Then smoke-test in a FRESH session.</a:t>
+              <a:t>The (NFR-0002) tag is a citation, not a loader.</a:t>
             </a:r>
           </a:p>
         </p:txBody>

</xml_diff>